<commit_message>
feat: architecture deck, manifest, updated pitch with advisor credit on all slides
</commit_message>
<xml_diff>
--- a/Santander_Digital_Banking_Future.pptx
+++ b/Santander_Digital_Banking_Future.pptx
@@ -3519,7 +3519,120 @@
       </p:sp>
       <p:sp>
         <p:nvSpPr>
-          <p:cNvPr id="13" name="TextBox 12"/>
+          <p:cNvPr id="13" name="Rectangle 12"/>
+          <p:cNvSpPr/>
+          <p:nvPr/>
+        </p:nvSpPr>
+        <p:spPr>
+          <a:xfrm>
+            <a:off x="3200400" y="5230368"/>
+            <a:ext cx="5788152" cy="658368"/>
+          </a:xfrm>
+          <a:prstGeom prst="rect">
+            <a:avLst/>
+          </a:prstGeom>
+          <a:solidFill>
+            <a:srgbClr val="C8102E"/>
+          </a:solidFill>
+          <a:ln>
+            <a:noFill/>
+          </a:ln>
+        </p:spPr>
+        <p:style>
+          <a:lnRef idx="1">
+            <a:schemeClr val="accent1"/>
+          </a:lnRef>
+          <a:fillRef idx="3">
+            <a:schemeClr val="accent1"/>
+          </a:fillRef>
+          <a:effectRef idx="2">
+            <a:schemeClr val="accent1"/>
+          </a:effectRef>
+          <a:fontRef idx="minor">
+            <a:schemeClr val="lt1"/>
+          </a:fontRef>
+        </p:style>
+        <p:txBody>
+          <a:bodyPr rtlCol="0" anchor="ctr"/>
+          <a:lstStyle/>
+          <a:p>
+            <a:pPr algn="ctr"/>
+          </a:p>
+        </p:txBody>
+      </p:sp>
+      <p:sp>
+        <p:nvSpPr>
+          <p:cNvPr id="14" name="TextBox 13"/>
+          <p:cNvSpPr txBox="1"/>
+          <p:nvPr/>
+        </p:nvSpPr>
+        <p:spPr>
+          <a:xfrm>
+            <a:off x="3200400" y="5266944"/>
+            <a:ext cx="5788152" cy="274320"/>
+          </a:xfrm>
+          <a:prstGeom prst="rect">
+            <a:avLst/>
+          </a:prstGeom>
+          <a:noFill/>
+        </p:spPr>
+        <p:txBody>
+          <a:bodyPr wrap="square">
+            <a:spAutoFit/>
+          </a:bodyPr>
+          <a:lstStyle/>
+          <a:p>
+            <a:pPr algn="ctr"/>
+            <a:r>
+              <a:rPr sz="1100" b="1" i="0">
+                <a:solidFill>
+                  <a:srgbClr val="FFFFFF"/>
+                </a:solidFill>
+                <a:latin typeface="Calibri"/>
+              </a:rPr>
+              <a:t>BUSINESS BANKING ADVISOR</a:t>
+            </a:r>
+          </a:p>
+        </p:txBody>
+      </p:sp>
+      <p:sp>
+        <p:nvSpPr>
+          <p:cNvPr id="15" name="TextBox 14"/>
+          <p:cNvSpPr txBox="1"/>
+          <p:nvPr/>
+        </p:nvSpPr>
+        <p:spPr>
+          <a:xfrm>
+            <a:off x="3200400" y="5550408"/>
+            <a:ext cx="5788152" cy="274320"/>
+          </a:xfrm>
+          <a:prstGeom prst="rect">
+            <a:avLst/>
+          </a:prstGeom>
+          <a:noFill/>
+        </p:spPr>
+        <p:txBody>
+          <a:bodyPr wrap="square">
+            <a:spAutoFit/>
+          </a:bodyPr>
+          <a:lstStyle/>
+          <a:p>
+            <a:pPr algn="ctr"/>
+            <a:r>
+              <a:rPr sz="900" b="0" i="1">
+                <a:solidFill>
+                  <a:srgbClr val="FECACA"/>
+                </a:solidFill>
+                <a:latin typeface="Calibri"/>
+              </a:rPr>
+              <a:t>Self-initiated  ·  Completed out of hours  ·  Own time</a:t>
+            </a:r>
+          </a:p>
+        </p:txBody>
+      </p:sp>
+      <p:sp>
+        <p:nvSpPr>
+          <p:cNvPr id="16" name="TextBox 15"/>
           <p:cNvSpPr txBox="1"/>
           <p:nvPr/>
         </p:nvSpPr>
@@ -4675,6 +4788,41 @@
         </p:nvSpPr>
         <p:spPr>
           <a:xfrm>
+            <a:off x="457200" y="6601968"/>
+            <a:ext cx="10515600" cy="219456"/>
+          </a:xfrm>
+          <a:prstGeom prst="rect">
+            <a:avLst/>
+          </a:prstGeom>
+          <a:noFill/>
+        </p:spPr>
+        <p:txBody>
+          <a:bodyPr wrap="square">
+            <a:spAutoFit/>
+          </a:bodyPr>
+          <a:lstStyle/>
+          <a:p>
+            <a:pPr algn="l"/>
+            <a:r>
+              <a:rPr sz="750" b="0" i="1">
+                <a:solidFill>
+                  <a:srgbClr val="78716C"/>
+                </a:solidFill>
+                <a:latin typeface="Calibri"/>
+              </a:rPr>
+              <a:t>Business Banking Advisor  ·  Self-initiated  ·  Completed out of hours in own time</a:t>
+            </a:r>
+          </a:p>
+        </p:txBody>
+      </p:sp>
+      <p:sp>
+        <p:nvSpPr>
+          <p:cNvPr id="27" name="TextBox 26"/>
+          <p:cNvSpPr txBox="1"/>
+          <p:nvPr/>
+        </p:nvSpPr>
+        <p:spPr>
+          <a:xfrm>
             <a:off x="11521440" y="6492240"/>
             <a:ext cx="457200" cy="274320"/>
           </a:xfrm>
@@ -6198,6 +6346,41 @@
         </p:nvSpPr>
         <p:spPr>
           <a:xfrm>
+            <a:off x="457200" y="6601968"/>
+            <a:ext cx="10515600" cy="219456"/>
+          </a:xfrm>
+          <a:prstGeom prst="rect">
+            <a:avLst/>
+          </a:prstGeom>
+          <a:noFill/>
+        </p:spPr>
+        <p:txBody>
+          <a:bodyPr wrap="square">
+            <a:spAutoFit/>
+          </a:bodyPr>
+          <a:lstStyle/>
+          <a:p>
+            <a:pPr algn="l"/>
+            <a:r>
+              <a:rPr sz="750" b="0" i="1">
+                <a:solidFill>
+                  <a:srgbClr val="78716C"/>
+                </a:solidFill>
+                <a:latin typeface="Calibri"/>
+              </a:rPr>
+              <a:t>Business Banking Advisor  ·  Self-initiated  ·  Completed out of hours in own time</a:t>
+            </a:r>
+          </a:p>
+        </p:txBody>
+      </p:sp>
+      <p:sp>
+        <p:nvSpPr>
+          <p:cNvPr id="29" name="TextBox 28"/>
+          <p:cNvSpPr txBox="1"/>
+          <p:nvPr/>
+        </p:nvSpPr>
+        <p:spPr>
+          <a:xfrm>
             <a:off x="11521440" y="6492240"/>
             <a:ext cx="457200" cy="274320"/>
           </a:xfrm>
@@ -8517,6 +8700,41 @@
         </p:nvSpPr>
         <p:spPr>
           <a:xfrm>
+            <a:off x="457200" y="6601968"/>
+            <a:ext cx="10515600" cy="219456"/>
+          </a:xfrm>
+          <a:prstGeom prst="rect">
+            <a:avLst/>
+          </a:prstGeom>
+          <a:noFill/>
+        </p:spPr>
+        <p:txBody>
+          <a:bodyPr wrap="square">
+            <a:spAutoFit/>
+          </a:bodyPr>
+          <a:lstStyle/>
+          <a:p>
+            <a:pPr algn="l"/>
+            <a:r>
+              <a:rPr sz="750" b="0" i="1">
+                <a:solidFill>
+                  <a:srgbClr val="78716C"/>
+                </a:solidFill>
+                <a:latin typeface="Calibri"/>
+              </a:rPr>
+              <a:t>Business Banking Advisor  ·  Self-initiated  ·  Completed out of hours in own time</a:t>
+            </a:r>
+          </a:p>
+        </p:txBody>
+      </p:sp>
+      <p:sp>
+        <p:nvSpPr>
+          <p:cNvPr id="59" name="TextBox 58"/>
+          <p:cNvSpPr txBox="1"/>
+          <p:nvPr/>
+        </p:nvSpPr>
+        <p:spPr>
+          <a:xfrm>
             <a:off x="11521440" y="6492240"/>
             <a:ext cx="457200" cy="274320"/>
           </a:xfrm>
@@ -9428,23 +9646,23 @@
         </p:nvSpPr>
         <p:spPr>
           <a:xfrm>
-            <a:off x="822960" y="6108192"/>
-            <a:ext cx="10515600" cy="457200"/>
-          </a:xfrm>
-          <a:prstGeom prst="rect">
-            <a:avLst/>
-          </a:prstGeom>
-          <a:noFill/>
-        </p:spPr>
-        <p:txBody>
-          <a:bodyPr wrap="square">
-            <a:spAutoFit/>
-          </a:bodyPr>
-          <a:lstStyle/>
-          <a:p>
-            <a:pPr algn="ctr"/>
-            <a:r>
-              <a:rPr sz="1100" b="1" i="0">
+            <a:off x="822960" y="5760720"/>
+            <a:ext cx="10515600" cy="320040"/>
+          </a:xfrm>
+          <a:prstGeom prst="rect">
+            <a:avLst/>
+          </a:prstGeom>
+          <a:noFill/>
+        </p:spPr>
+        <p:txBody>
+          <a:bodyPr wrap="square">
+            <a:spAutoFit/>
+          </a:bodyPr>
+          <a:lstStyle/>
+          <a:p>
+            <a:pPr algn="ctr"/>
+            <a:r>
+              <a:rPr sz="1000" b="1" i="0">
                 <a:solidFill>
                   <a:srgbClr val="FFFFFF"/>
                 </a:solidFill>
@@ -9458,6 +9676,41 @@
       <p:sp>
         <p:nvSpPr>
           <p:cNvPr id="25" name="TextBox 24"/>
+          <p:cNvSpPr txBox="1"/>
+          <p:nvPr/>
+        </p:nvSpPr>
+        <p:spPr>
+          <a:xfrm>
+            <a:off x="822960" y="6080760"/>
+            <a:ext cx="10515600" cy="274320"/>
+          </a:xfrm>
+          <a:prstGeom prst="rect">
+            <a:avLst/>
+          </a:prstGeom>
+          <a:noFill/>
+        </p:spPr>
+        <p:txBody>
+          <a:bodyPr wrap="square">
+            <a:spAutoFit/>
+          </a:bodyPr>
+          <a:lstStyle/>
+          <a:p>
+            <a:pPr algn="ctr"/>
+            <a:r>
+              <a:rPr sz="900" b="0" i="1">
+                <a:solidFill>
+                  <a:srgbClr val="FECACA"/>
+                </a:solidFill>
+                <a:latin typeface="Calibri"/>
+              </a:rPr>
+              <a:t>Business Banking Advisor  ·  Self-initiated  ·  Completed entirely out of hours in own time</a:t>
+            </a:r>
+          </a:p>
+        </p:txBody>
+      </p:sp>
+      <p:sp>
+        <p:nvSpPr>
+          <p:cNvPr id="26" name="TextBox 25"/>
           <p:cNvSpPr txBox="1"/>
           <p:nvPr/>
         </p:nvSpPr>
@@ -10774,6 +11027,41 @@
         </p:nvSpPr>
         <p:spPr>
           <a:xfrm>
+            <a:off x="457200" y="6601968"/>
+            <a:ext cx="10515600" cy="219456"/>
+          </a:xfrm>
+          <a:prstGeom prst="rect">
+            <a:avLst/>
+          </a:prstGeom>
+          <a:noFill/>
+        </p:spPr>
+        <p:txBody>
+          <a:bodyPr wrap="square">
+            <a:spAutoFit/>
+          </a:bodyPr>
+          <a:lstStyle/>
+          <a:p>
+            <a:pPr algn="l"/>
+            <a:r>
+              <a:rPr sz="750" b="0" i="1">
+                <a:solidFill>
+                  <a:srgbClr val="78716C"/>
+                </a:solidFill>
+                <a:latin typeface="Calibri"/>
+              </a:rPr>
+              <a:t>Business Banking Advisor  ·  Self-initiated  ·  Completed out of hours in own time</a:t>
+            </a:r>
+          </a:p>
+        </p:txBody>
+      </p:sp>
+      <p:sp>
+        <p:nvSpPr>
+          <p:cNvPr id="29" name="TextBox 28"/>
+          <p:cNvSpPr txBox="1"/>
+          <p:nvPr/>
+        </p:nvSpPr>
+        <p:spPr>
+          <a:xfrm>
             <a:off x="11521440" y="6492240"/>
             <a:ext cx="457200" cy="274320"/>
           </a:xfrm>
@@ -11970,6 +12258,41 @@
         </p:nvSpPr>
         <p:spPr>
           <a:xfrm>
+            <a:off x="457200" y="6601968"/>
+            <a:ext cx="10515600" cy="219456"/>
+          </a:xfrm>
+          <a:prstGeom prst="rect">
+            <a:avLst/>
+          </a:prstGeom>
+          <a:noFill/>
+        </p:spPr>
+        <p:txBody>
+          <a:bodyPr wrap="square">
+            <a:spAutoFit/>
+          </a:bodyPr>
+          <a:lstStyle/>
+          <a:p>
+            <a:pPr algn="l"/>
+            <a:r>
+              <a:rPr sz="750" b="0" i="1">
+                <a:solidFill>
+                  <a:srgbClr val="78716C"/>
+                </a:solidFill>
+                <a:latin typeface="Calibri"/>
+              </a:rPr>
+              <a:t>Business Banking Advisor  ·  Self-initiated  ·  Completed out of hours in own time</a:t>
+            </a:r>
+          </a:p>
+        </p:txBody>
+      </p:sp>
+      <p:sp>
+        <p:nvSpPr>
+          <p:cNvPr id="32" name="TextBox 31"/>
+          <p:cNvSpPr txBox="1"/>
+          <p:nvPr/>
+        </p:nvSpPr>
+        <p:spPr>
+          <a:xfrm>
             <a:off x="11521440" y="6492240"/>
             <a:ext cx="457200" cy="274320"/>
           </a:xfrm>
@@ -13802,6 +14125,41 @@
         </p:nvSpPr>
         <p:spPr>
           <a:xfrm>
+            <a:off x="457200" y="6601968"/>
+            <a:ext cx="10515600" cy="219456"/>
+          </a:xfrm>
+          <a:prstGeom prst="rect">
+            <a:avLst/>
+          </a:prstGeom>
+          <a:noFill/>
+        </p:spPr>
+        <p:txBody>
+          <a:bodyPr wrap="square">
+            <a:spAutoFit/>
+          </a:bodyPr>
+          <a:lstStyle/>
+          <a:p>
+            <a:pPr algn="l"/>
+            <a:r>
+              <a:rPr sz="750" b="0" i="1">
+                <a:solidFill>
+                  <a:srgbClr val="78716C"/>
+                </a:solidFill>
+                <a:latin typeface="Calibri"/>
+              </a:rPr>
+              <a:t>Business Banking Advisor  ·  Self-initiated  ·  Completed out of hours in own time</a:t>
+            </a:r>
+          </a:p>
+        </p:txBody>
+      </p:sp>
+      <p:sp>
+        <p:nvSpPr>
+          <p:cNvPr id="48" name="TextBox 47"/>
+          <p:cNvSpPr txBox="1"/>
+          <p:nvPr/>
+        </p:nvSpPr>
+        <p:spPr>
+          <a:xfrm>
             <a:off x="11521440" y="6492240"/>
             <a:ext cx="457200" cy="274320"/>
           </a:xfrm>
@@ -15831,6 +16189,41 @@
         </p:nvSpPr>
         <p:spPr>
           <a:xfrm>
+            <a:off x="457200" y="6601968"/>
+            <a:ext cx="10515600" cy="219456"/>
+          </a:xfrm>
+          <a:prstGeom prst="rect">
+            <a:avLst/>
+          </a:prstGeom>
+          <a:noFill/>
+        </p:spPr>
+        <p:txBody>
+          <a:bodyPr wrap="square">
+            <a:spAutoFit/>
+          </a:bodyPr>
+          <a:lstStyle/>
+          <a:p>
+            <a:pPr algn="l"/>
+            <a:r>
+              <a:rPr sz="750" b="0" i="1">
+                <a:solidFill>
+                  <a:srgbClr val="78716C"/>
+                </a:solidFill>
+                <a:latin typeface="Calibri"/>
+              </a:rPr>
+              <a:t>Business Banking Advisor  ·  Self-initiated  ·  Completed out of hours in own time</a:t>
+            </a:r>
+          </a:p>
+        </p:txBody>
+      </p:sp>
+      <p:sp>
+        <p:nvSpPr>
+          <p:cNvPr id="55" name="TextBox 54"/>
+          <p:cNvSpPr txBox="1"/>
+          <p:nvPr/>
+        </p:nvSpPr>
+        <p:spPr>
+          <a:xfrm>
             <a:off x="11521440" y="6492240"/>
             <a:ext cx="457200" cy="274320"/>
           </a:xfrm>
@@ -17612,6 +18005,41 @@
         </p:nvSpPr>
         <p:spPr>
           <a:xfrm>
+            <a:off x="457200" y="6601968"/>
+            <a:ext cx="10515600" cy="219456"/>
+          </a:xfrm>
+          <a:prstGeom prst="rect">
+            <a:avLst/>
+          </a:prstGeom>
+          <a:noFill/>
+        </p:spPr>
+        <p:txBody>
+          <a:bodyPr wrap="square">
+            <a:spAutoFit/>
+          </a:bodyPr>
+          <a:lstStyle/>
+          <a:p>
+            <a:pPr algn="l"/>
+            <a:r>
+              <a:rPr sz="750" b="0" i="1">
+                <a:solidFill>
+                  <a:srgbClr val="78716C"/>
+                </a:solidFill>
+                <a:latin typeface="Calibri"/>
+              </a:rPr>
+              <a:t>Business Banking Advisor  ·  Self-initiated  ·  Completed out of hours in own time</a:t>
+            </a:r>
+          </a:p>
+        </p:txBody>
+      </p:sp>
+      <p:sp>
+        <p:nvSpPr>
+          <p:cNvPr id="43" name="TextBox 42"/>
+          <p:cNvSpPr txBox="1"/>
+          <p:nvPr/>
+        </p:nvSpPr>
+        <p:spPr>
+          <a:xfrm>
             <a:off x="11521440" y="6492240"/>
             <a:ext cx="457200" cy="274320"/>
           </a:xfrm>
@@ -18938,6 +19366,41 @@
         </p:nvSpPr>
         <p:spPr>
           <a:xfrm>
+            <a:off x="457200" y="6601968"/>
+            <a:ext cx="10515600" cy="219456"/>
+          </a:xfrm>
+          <a:prstGeom prst="rect">
+            <a:avLst/>
+          </a:prstGeom>
+          <a:noFill/>
+        </p:spPr>
+        <p:txBody>
+          <a:bodyPr wrap="square">
+            <a:spAutoFit/>
+          </a:bodyPr>
+          <a:lstStyle/>
+          <a:p>
+            <a:pPr algn="l"/>
+            <a:r>
+              <a:rPr sz="750" b="0" i="1">
+                <a:solidFill>
+                  <a:srgbClr val="78716C"/>
+                </a:solidFill>
+                <a:latin typeface="Calibri"/>
+              </a:rPr>
+              <a:t>Business Banking Advisor  ·  Self-initiated  ·  Completed out of hours in own time</a:t>
+            </a:r>
+          </a:p>
+        </p:txBody>
+      </p:sp>
+      <p:sp>
+        <p:nvSpPr>
+          <p:cNvPr id="23" name="TextBox 22"/>
+          <p:cNvSpPr txBox="1"/>
+          <p:nvPr/>
+        </p:nvSpPr>
+        <p:spPr>
+          <a:xfrm>
             <a:off x="11521440" y="6492240"/>
             <a:ext cx="457200" cy="274320"/>
           </a:xfrm>
@@ -20276,6 +20739,41 @@
         </p:nvSpPr>
         <p:spPr>
           <a:xfrm>
+            <a:off x="457200" y="6601968"/>
+            <a:ext cx="10515600" cy="219456"/>
+          </a:xfrm>
+          <a:prstGeom prst="rect">
+            <a:avLst/>
+          </a:prstGeom>
+          <a:noFill/>
+        </p:spPr>
+        <p:txBody>
+          <a:bodyPr wrap="square">
+            <a:spAutoFit/>
+          </a:bodyPr>
+          <a:lstStyle/>
+          <a:p>
+            <a:pPr algn="l"/>
+            <a:r>
+              <a:rPr sz="750" b="0" i="1">
+                <a:solidFill>
+                  <a:srgbClr val="78716C"/>
+                </a:solidFill>
+                <a:latin typeface="Calibri"/>
+              </a:rPr>
+              <a:t>Business Banking Advisor  ·  Self-initiated  ·  Completed out of hours in own time</a:t>
+            </a:r>
+          </a:p>
+        </p:txBody>
+      </p:sp>
+      <p:sp>
+        <p:nvSpPr>
+          <p:cNvPr id="27" name="TextBox 26"/>
+          <p:cNvSpPr txBox="1"/>
+          <p:nvPr/>
+        </p:nvSpPr>
+        <p:spPr>
+          <a:xfrm>
             <a:off x="11521440" y="6492240"/>
             <a:ext cx="457200" cy="274320"/>
           </a:xfrm>
@@ -22140,6 +22638,41 @@
       <p:sp>
         <p:nvSpPr>
           <p:cNvPr id="50" name="TextBox 49"/>
+          <p:cNvSpPr txBox="1"/>
+          <p:nvPr/>
+        </p:nvSpPr>
+        <p:spPr>
+          <a:xfrm>
+            <a:off x="457200" y="6601968"/>
+            <a:ext cx="10515600" cy="219456"/>
+          </a:xfrm>
+          <a:prstGeom prst="rect">
+            <a:avLst/>
+          </a:prstGeom>
+          <a:noFill/>
+        </p:spPr>
+        <p:txBody>
+          <a:bodyPr wrap="square">
+            <a:spAutoFit/>
+          </a:bodyPr>
+          <a:lstStyle/>
+          <a:p>
+            <a:pPr algn="l"/>
+            <a:r>
+              <a:rPr sz="750" b="0" i="1">
+                <a:solidFill>
+                  <a:srgbClr val="78716C"/>
+                </a:solidFill>
+                <a:latin typeface="Calibri"/>
+              </a:rPr>
+              <a:t>Business Banking Advisor  ·  Self-initiated  ·  Completed out of hours in own time</a:t>
+            </a:r>
+          </a:p>
+        </p:txBody>
+      </p:sp>
+      <p:sp>
+        <p:nvSpPr>
+          <p:cNvPr id="51" name="TextBox 50"/>
           <p:cNvSpPr txBox="1"/>
           <p:nvPr/>
         </p:nvSpPr>

</xml_diff>

<commit_message>
docs: update all deliverables — 21 features, notification bell added
MANIFEST.md: line count updated (~5,300), 5 sheet overlays, build
size corrected (832KB), notification bell added to security table,
8th compliance framework (FCA SYSC 10A), 21 features count.

build_deck.py: features list 20→21, slide 7 subtitle "Six→Seven
features", notification bell added as 7th panel, slide 7 layout
fixed (3+4 panel arrangement, correct row formula).

PowerPoints regenerated: both decks rebuilt from updated scripts.

Co-Authored-By: Claude Sonnet 4.6 <noreply@anthropic.com>
Claude-Session: https://claude.ai/code/session_012EFETGbhdxdnPCjpmQ9UDz
</commit_message>
<xml_diff>
--- a/Santander_Digital_Banking_Future.pptx
+++ b/Santander_Digital_Banking_Future.pptx
@@ -17199,7 +17199,7 @@
                 </a:solidFill>
                 <a:latin typeface="Calibri"/>
               </a:rPr>
-              <a:t>A single-page React application — running live in any browser, no server, no backend — demonstrating every critical business banking workflow end-to-end. 20 features across 4 areas.</a:t>
+              <a:t>A single-page React application — running live in any browser, no server, no backend — demonstrating every critical business banking workflow end-to-end. 21 features across 4 areas.</a:t>
             </a:r>
           </a:p>
         </p:txBody>
@@ -20366,7 +20366,165 @@
       </p:sp>
       <p:sp>
         <p:nvSpPr>
-          <p:cNvPr id="87" name="TextBox 86"/>
+          <p:cNvPr id="87" name="Rectangle 86"/>
+          <p:cNvSpPr/>
+          <p:nvPr/>
+        </p:nvSpPr>
+        <p:spPr>
+          <a:xfrm>
+            <a:off x="502920" y="6172200"/>
+            <a:ext cx="2697480" cy="804672"/>
+          </a:xfrm>
+          <a:prstGeom prst="rect">
+            <a:avLst/>
+          </a:prstGeom>
+          <a:solidFill>
+            <a:srgbClr val="FFFFFF"/>
+          </a:solidFill>
+          <a:ln w="12700">
+            <a:solidFill>
+              <a:srgbClr val="D6D3D1"/>
+            </a:solidFill>
+          </a:ln>
+        </p:spPr>
+        <p:style>
+          <a:lnRef idx="1">
+            <a:schemeClr val="accent1"/>
+          </a:lnRef>
+          <a:fillRef idx="3">
+            <a:schemeClr val="accent1"/>
+          </a:fillRef>
+          <a:effectRef idx="2">
+            <a:schemeClr val="accent1"/>
+          </a:effectRef>
+          <a:fontRef idx="minor">
+            <a:schemeClr val="lt1"/>
+          </a:fontRef>
+        </p:style>
+        <p:txBody>
+          <a:bodyPr rtlCol="0" anchor="ctr"/>
+          <a:lstStyle/>
+          <a:p>
+            <a:pPr algn="ctr"/>
+          </a:p>
+        </p:txBody>
+      </p:sp>
+      <p:sp>
+        <p:nvSpPr>
+          <p:cNvPr id="88" name="Rectangle 87"/>
+          <p:cNvSpPr/>
+          <p:nvPr/>
+        </p:nvSpPr>
+        <p:spPr>
+          <a:xfrm>
+            <a:off x="502920" y="6172200"/>
+            <a:ext cx="73152" cy="804672"/>
+          </a:xfrm>
+          <a:prstGeom prst="rect">
+            <a:avLst/>
+          </a:prstGeom>
+          <a:solidFill>
+            <a:srgbClr val="C8102E"/>
+          </a:solidFill>
+          <a:ln>
+            <a:noFill/>
+          </a:ln>
+        </p:spPr>
+        <p:style>
+          <a:lnRef idx="1">
+            <a:schemeClr val="accent1"/>
+          </a:lnRef>
+          <a:fillRef idx="3">
+            <a:schemeClr val="accent1"/>
+          </a:fillRef>
+          <a:effectRef idx="2">
+            <a:schemeClr val="accent1"/>
+          </a:effectRef>
+          <a:fontRef idx="minor">
+            <a:schemeClr val="lt1"/>
+          </a:fontRef>
+        </p:style>
+        <p:txBody>
+          <a:bodyPr rtlCol="0" anchor="ctr"/>
+          <a:lstStyle/>
+          <a:p>
+            <a:pPr algn="ctr"/>
+          </a:p>
+        </p:txBody>
+      </p:sp>
+      <p:sp>
+        <p:nvSpPr>
+          <p:cNvPr id="89" name="TextBox 88"/>
+          <p:cNvSpPr txBox="1"/>
+          <p:nvPr/>
+        </p:nvSpPr>
+        <p:spPr>
+          <a:xfrm>
+            <a:off x="704088" y="6227064"/>
+            <a:ext cx="2377440" cy="256032"/>
+          </a:xfrm>
+          <a:prstGeom prst="rect">
+            <a:avLst/>
+          </a:prstGeom>
+          <a:noFill/>
+        </p:spPr>
+        <p:txBody>
+          <a:bodyPr wrap="square">
+            <a:spAutoFit/>
+          </a:bodyPr>
+          <a:lstStyle/>
+          <a:p>
+            <a:pPr algn="l"/>
+            <a:r>
+              <a:rPr sz="900" b="1" i="0">
+                <a:solidFill>
+                  <a:srgbClr val="1C1917"/>
+                </a:solidFill>
+                <a:latin typeface="Calibri"/>
+              </a:rPr>
+              <a:t>Live notifications</a:t>
+            </a:r>
+          </a:p>
+        </p:txBody>
+      </p:sp>
+      <p:sp>
+        <p:nvSpPr>
+          <p:cNvPr id="90" name="TextBox 89"/>
+          <p:cNvSpPr txBox="1"/>
+          <p:nvPr/>
+        </p:nvSpPr>
+        <p:spPr>
+          <a:xfrm>
+            <a:off x="704088" y="6483096"/>
+            <a:ext cx="2423160" cy="438912"/>
+          </a:xfrm>
+          <a:prstGeom prst="rect">
+            <a:avLst/>
+          </a:prstGeom>
+          <a:noFill/>
+        </p:spPr>
+        <p:txBody>
+          <a:bodyPr wrap="square">
+            <a:spAutoFit/>
+          </a:bodyPr>
+          <a:lstStyle/>
+          <a:p>
+            <a:pPr algn="l"/>
+            <a:r>
+              <a:rPr sz="800" b="0" i="0">
+                <a:solidFill>
+                  <a:srgbClr val="78716C"/>
+                </a:solidFill>
+                <a:latin typeface="Calibri"/>
+              </a:rPr>
+              <a:t>Bell icon · security alerts · approvals · cooling-off · co-signer status</a:t>
+            </a:r>
+          </a:p>
+        </p:txBody>
+      </p:sp>
+      <p:sp>
+        <p:nvSpPr>
+          <p:cNvPr id="91" name="TextBox 90"/>
           <p:cNvSpPr txBox="1"/>
           <p:nvPr/>
         </p:nvSpPr>
@@ -20401,7 +20559,7 @@
       </p:sp>
       <p:sp>
         <p:nvSpPr>
-          <p:cNvPr id="88" name="TextBox 87"/>
+          <p:cNvPr id="92" name="TextBox 91"/>
           <p:cNvSpPr txBox="1"/>
           <p:nvPr/>
         </p:nvSpPr>
@@ -23717,7 +23875,7 @@
         <p:spPr>
           <a:xfrm>
             <a:off x="457200" y="640080"/>
-            <a:ext cx="9144000" cy="320040"/>
+            <a:ext cx="10972800" cy="320040"/>
           </a:xfrm>
           <a:prstGeom prst="rect">
             <a:avLst/>
@@ -23738,7 +23896,7 @@
                 </a:solidFill>
                 <a:latin typeface="Calibri"/>
               </a:rPr>
-              <a:t>Six features that set us apart — intelligence built in, security by design</a:t>
+              <a:t>Seven features that set us apart — intelligence built in, security by design</a:t>
             </a:r>
           </a:p>
         </p:txBody>
@@ -23795,7 +23953,7 @@
         <p:spPr>
           <a:xfrm>
             <a:off x="411480" y="1097280"/>
-            <a:ext cx="3749039" cy="2331720"/>
+            <a:ext cx="3648456" cy="2377440"/>
           </a:xfrm>
           <a:prstGeom prst="rect">
             <a:avLst/>
@@ -23840,7 +23998,7 @@
         <p:spPr>
           <a:xfrm>
             <a:off x="411480" y="1097280"/>
-            <a:ext cx="3749039" cy="64008"/>
+            <a:ext cx="3648456" cy="64008"/>
           </a:xfrm>
           <a:prstGeom prst="rect">
             <a:avLst/>
@@ -23882,8 +24040,8 @@
         </p:nvSpPr>
         <p:spPr>
           <a:xfrm>
-            <a:off x="576072" y="1207007"/>
-            <a:ext cx="3474720" cy="292608"/>
+            <a:off x="548640" y="1207007"/>
+            <a:ext cx="3465576" cy="292608"/>
           </a:xfrm>
           <a:prstGeom prst="rect">
             <a:avLst/>
@@ -23898,7 +24056,7 @@
           <a:p>
             <a:pPr algn="l"/>
             <a:r>
-              <a:rPr sz="1050" b="1" i="0">
+              <a:rPr sz="1000" b="1" i="0">
                 <a:solidFill>
                   <a:srgbClr val="1C1917"/>
                 </a:solidFill>
@@ -23917,8 +24075,8 @@
         </p:nvSpPr>
         <p:spPr>
           <a:xfrm>
-            <a:off x="576072" y="1554480"/>
-            <a:ext cx="3474720" cy="5486400"/>
+            <a:off x="548640" y="1554480"/>
+            <a:ext cx="3465576" cy="5486400"/>
           </a:xfrm>
           <a:prstGeom prst="rect">
             <a:avLst/>
@@ -23937,7 +24095,7 @@
               </a:spcAft>
             </a:pPr>
             <a:r>
-              <a:rPr sz="900">
+              <a:rPr sz="850">
                 <a:solidFill>
                   <a:srgbClr val="C8102E"/>
                 </a:solidFill>
@@ -23946,7 +24104,7 @@
               <a:t>▪  </a:t>
             </a:r>
             <a:r>
-              <a:rPr sz="900">
+              <a:rPr sz="850">
                 <a:solidFill>
                   <a:srgbClr val="78716C"/>
                 </a:solidFill>
@@ -23962,7 +24120,7 @@
               </a:spcAft>
             </a:pPr>
             <a:r>
-              <a:rPr sz="900">
+              <a:rPr sz="850">
                 <a:solidFill>
                   <a:srgbClr val="C8102E"/>
                 </a:solidFill>
@@ -23971,7 +24129,7 @@
               <a:t>▪  </a:t>
             </a:r>
             <a:r>
-              <a:rPr sz="900">
+              <a:rPr sz="850">
                 <a:solidFill>
                   <a:srgbClr val="78716C"/>
                 </a:solidFill>
@@ -23987,7 +24145,7 @@
               </a:spcAft>
             </a:pPr>
             <a:r>
-              <a:rPr sz="900">
+              <a:rPr sz="850">
                 <a:solidFill>
                   <a:srgbClr val="C8102E"/>
                 </a:solidFill>
@@ -23996,7 +24154,7 @@
               <a:t>▪  </a:t>
             </a:r>
             <a:r>
-              <a:rPr sz="900">
+              <a:rPr sz="850">
                 <a:solidFill>
                   <a:srgbClr val="78716C"/>
                 </a:solidFill>
@@ -24012,7 +24170,7 @@
               </a:spcAft>
             </a:pPr>
             <a:r>
-              <a:rPr sz="900">
+              <a:rPr sz="850">
                 <a:solidFill>
                   <a:srgbClr val="C8102E"/>
                 </a:solidFill>
@@ -24021,7 +24179,7 @@
               <a:t>▪  </a:t>
             </a:r>
             <a:r>
-              <a:rPr sz="900">
+              <a:rPr sz="850">
                 <a:solidFill>
                   <a:srgbClr val="78716C"/>
                 </a:solidFill>
@@ -24040,8 +24198,8 @@
         </p:nvSpPr>
         <p:spPr>
           <a:xfrm>
-            <a:off x="4343400" y="1097280"/>
-            <a:ext cx="3749039" cy="2331720"/>
+            <a:off x="4224528" y="1097280"/>
+            <a:ext cx="3648456" cy="2377440"/>
           </a:xfrm>
           <a:prstGeom prst="rect">
             <a:avLst/>
@@ -24085,8 +24243,8 @@
         </p:nvSpPr>
         <p:spPr>
           <a:xfrm>
-            <a:off x="4343400" y="1097280"/>
-            <a:ext cx="3749039" cy="64008"/>
+            <a:off x="4224528" y="1097280"/>
+            <a:ext cx="3648456" cy="64008"/>
           </a:xfrm>
           <a:prstGeom prst="rect">
             <a:avLst/>
@@ -24128,8 +24286,8 @@
         </p:nvSpPr>
         <p:spPr>
           <a:xfrm>
-            <a:off x="4507992" y="1207007"/>
-            <a:ext cx="3474720" cy="292608"/>
+            <a:off x="4361688" y="1207007"/>
+            <a:ext cx="3465576" cy="292608"/>
           </a:xfrm>
           <a:prstGeom prst="rect">
             <a:avLst/>
@@ -24144,7 +24302,7 @@
           <a:p>
             <a:pPr algn="l"/>
             <a:r>
-              <a:rPr sz="1050" b="1" i="0">
+              <a:rPr sz="1000" b="1" i="0">
                 <a:solidFill>
                   <a:srgbClr val="1C1917"/>
                 </a:solidFill>
@@ -24163,8 +24321,8 @@
         </p:nvSpPr>
         <p:spPr>
           <a:xfrm>
-            <a:off x="4507992" y="1554480"/>
-            <a:ext cx="3474720" cy="5486400"/>
+            <a:off x="4361688" y="1554480"/>
+            <a:ext cx="3465576" cy="5486400"/>
           </a:xfrm>
           <a:prstGeom prst="rect">
             <a:avLst/>
@@ -24183,7 +24341,7 @@
               </a:spcAft>
             </a:pPr>
             <a:r>
-              <a:rPr sz="900">
+              <a:rPr sz="850">
                 <a:solidFill>
                   <a:srgbClr val="C8102E"/>
                 </a:solidFill>
@@ -24192,7 +24350,7 @@
               <a:t>▪  </a:t>
             </a:r>
             <a:r>
-              <a:rPr sz="900">
+              <a:rPr sz="850">
                 <a:solidFill>
                   <a:srgbClr val="78716C"/>
                 </a:solidFill>
@@ -24208,7 +24366,7 @@
               </a:spcAft>
             </a:pPr>
             <a:r>
-              <a:rPr sz="900">
+              <a:rPr sz="850">
                 <a:solidFill>
                   <a:srgbClr val="C8102E"/>
                 </a:solidFill>
@@ -24217,7 +24375,7 @@
               <a:t>▪  </a:t>
             </a:r>
             <a:r>
-              <a:rPr sz="900">
+              <a:rPr sz="850">
                 <a:solidFill>
                   <a:srgbClr val="78716C"/>
                 </a:solidFill>
@@ -24233,7 +24391,7 @@
               </a:spcAft>
             </a:pPr>
             <a:r>
-              <a:rPr sz="900">
+              <a:rPr sz="850">
                 <a:solidFill>
                   <a:srgbClr val="C8102E"/>
                 </a:solidFill>
@@ -24242,7 +24400,7 @@
               <a:t>▪  </a:t>
             </a:r>
             <a:r>
-              <a:rPr sz="900">
+              <a:rPr sz="850">
                 <a:solidFill>
                   <a:srgbClr val="78716C"/>
                 </a:solidFill>
@@ -24258,7 +24416,7 @@
               </a:spcAft>
             </a:pPr>
             <a:r>
-              <a:rPr sz="900">
+              <a:rPr sz="850">
                 <a:solidFill>
                   <a:srgbClr val="C8102E"/>
                 </a:solidFill>
@@ -24267,7 +24425,7 @@
               <a:t>▪  </a:t>
             </a:r>
             <a:r>
-              <a:rPr sz="900">
+              <a:rPr sz="850">
                 <a:solidFill>
                   <a:srgbClr val="78716C"/>
                 </a:solidFill>
@@ -24286,8 +24444,8 @@
         </p:nvSpPr>
         <p:spPr>
           <a:xfrm>
-            <a:off x="8275319" y="3584448"/>
-            <a:ext cx="3749039" cy="2331720"/>
+            <a:off x="8037575" y="1097280"/>
+            <a:ext cx="3648456" cy="2377440"/>
           </a:xfrm>
           <a:prstGeom prst="rect">
             <a:avLst/>
@@ -24331,8 +24489,8 @@
         </p:nvSpPr>
         <p:spPr>
           <a:xfrm>
-            <a:off x="8275319" y="3584448"/>
-            <a:ext cx="3749039" cy="64008"/>
+            <a:off x="8037575" y="1097280"/>
+            <a:ext cx="3648456" cy="64008"/>
           </a:xfrm>
           <a:prstGeom prst="rect">
             <a:avLst/>
@@ -24374,8 +24532,8 @@
         </p:nvSpPr>
         <p:spPr>
           <a:xfrm>
-            <a:off x="8439911" y="3694176"/>
-            <a:ext cx="3474720" cy="292608"/>
+            <a:off x="8174736" y="1207007"/>
+            <a:ext cx="3465576" cy="292608"/>
           </a:xfrm>
           <a:prstGeom prst="rect">
             <a:avLst/>
@@ -24390,7 +24548,7 @@
           <a:p>
             <a:pPr algn="l"/>
             <a:r>
-              <a:rPr sz="1050" b="1" i="0">
+              <a:rPr sz="1000" b="1" i="0">
                 <a:solidFill>
                   <a:srgbClr val="1C1917"/>
                 </a:solidFill>
@@ -24409,8 +24567,8 @@
         </p:nvSpPr>
         <p:spPr>
           <a:xfrm>
-            <a:off x="8439911" y="4041648"/>
-            <a:ext cx="3474720" cy="5486400"/>
+            <a:off x="8174736" y="1554480"/>
+            <a:ext cx="3465576" cy="5486400"/>
           </a:xfrm>
           <a:prstGeom prst="rect">
             <a:avLst/>
@@ -24429,7 +24587,7 @@
               </a:spcAft>
             </a:pPr>
             <a:r>
-              <a:rPr sz="900">
+              <a:rPr sz="850">
                 <a:solidFill>
                   <a:srgbClr val="C8102E"/>
                 </a:solidFill>
@@ -24438,7 +24596,7 @@
               <a:t>▪  </a:t>
             </a:r>
             <a:r>
-              <a:rPr sz="900">
+              <a:rPr sz="850">
                 <a:solidFill>
                   <a:srgbClr val="78716C"/>
                 </a:solidFill>
@@ -24454,7 +24612,7 @@
               </a:spcAft>
             </a:pPr>
             <a:r>
-              <a:rPr sz="900">
+              <a:rPr sz="850">
                 <a:solidFill>
                   <a:srgbClr val="C8102E"/>
                 </a:solidFill>
@@ -24463,7 +24621,7 @@
               <a:t>▪  </a:t>
             </a:r>
             <a:r>
-              <a:rPr sz="900">
+              <a:rPr sz="850">
                 <a:solidFill>
                   <a:srgbClr val="78716C"/>
                 </a:solidFill>
@@ -24479,7 +24637,7 @@
               </a:spcAft>
             </a:pPr>
             <a:r>
-              <a:rPr sz="900">
+              <a:rPr sz="850">
                 <a:solidFill>
                   <a:srgbClr val="C8102E"/>
                 </a:solidFill>
@@ -24488,7 +24646,7 @@
               <a:t>▪  </a:t>
             </a:r>
             <a:r>
-              <a:rPr sz="900">
+              <a:rPr sz="850">
                 <a:solidFill>
                   <a:srgbClr val="78716C"/>
                 </a:solidFill>
@@ -24504,7 +24662,7 @@
               </a:spcAft>
             </a:pPr>
             <a:r>
-              <a:rPr sz="900">
+              <a:rPr sz="850">
                 <a:solidFill>
                   <a:srgbClr val="C8102E"/>
                 </a:solidFill>
@@ -24513,7 +24671,7 @@
               <a:t>▪  </a:t>
             </a:r>
             <a:r>
-              <a:rPr sz="900">
+              <a:rPr sz="850">
                 <a:solidFill>
                   <a:srgbClr val="78716C"/>
                 </a:solidFill>
@@ -24532,8 +24690,8 @@
         </p:nvSpPr>
         <p:spPr>
           <a:xfrm>
-            <a:off x="411480" y="3584448"/>
-            <a:ext cx="3749039" cy="2331720"/>
+            <a:off x="411480" y="3703320"/>
+            <a:ext cx="2695194" cy="2377440"/>
           </a:xfrm>
           <a:prstGeom prst="rect">
             <a:avLst/>
@@ -24577,8 +24735,8 @@
         </p:nvSpPr>
         <p:spPr>
           <a:xfrm>
-            <a:off x="411480" y="3584448"/>
-            <a:ext cx="3749039" cy="64008"/>
+            <a:off x="411480" y="3703320"/>
+            <a:ext cx="2695194" cy="64008"/>
           </a:xfrm>
           <a:prstGeom prst="rect">
             <a:avLst/>
@@ -24620,8 +24778,8 @@
         </p:nvSpPr>
         <p:spPr>
           <a:xfrm>
-            <a:off x="576072" y="3694176"/>
-            <a:ext cx="3474720" cy="292608"/>
+            <a:off x="548640" y="3813048"/>
+            <a:ext cx="2512313" cy="292608"/>
           </a:xfrm>
           <a:prstGeom prst="rect">
             <a:avLst/>
@@ -24636,7 +24794,7 @@
           <a:p>
             <a:pPr algn="l"/>
             <a:r>
-              <a:rPr sz="1050" b="1" i="0">
+              <a:rPr sz="1000" b="1" i="0">
                 <a:solidFill>
                   <a:srgbClr val="1C1917"/>
                 </a:solidFill>
@@ -24655,8 +24813,8 @@
         </p:nvSpPr>
         <p:spPr>
           <a:xfrm>
-            <a:off x="576072" y="4041648"/>
-            <a:ext cx="3474720" cy="5486400"/>
+            <a:off x="548640" y="4160520"/>
+            <a:ext cx="2512313" cy="5486400"/>
           </a:xfrm>
           <a:prstGeom prst="rect">
             <a:avLst/>
@@ -24675,7 +24833,7 @@
               </a:spcAft>
             </a:pPr>
             <a:r>
-              <a:rPr sz="900">
+              <a:rPr sz="850">
                 <a:solidFill>
                   <a:srgbClr val="C8102E"/>
                 </a:solidFill>
@@ -24684,7 +24842,7 @@
               <a:t>▪  </a:t>
             </a:r>
             <a:r>
-              <a:rPr sz="900">
+              <a:rPr sz="850">
                 <a:solidFill>
                   <a:srgbClr val="78716C"/>
                 </a:solidFill>
@@ -24700,7 +24858,7 @@
               </a:spcAft>
             </a:pPr>
             <a:r>
-              <a:rPr sz="900">
+              <a:rPr sz="850">
                 <a:solidFill>
                   <a:srgbClr val="C8102E"/>
                 </a:solidFill>
@@ -24709,7 +24867,7 @@
               <a:t>▪  </a:t>
             </a:r>
             <a:r>
-              <a:rPr sz="900">
+              <a:rPr sz="850">
                 <a:solidFill>
                   <a:srgbClr val="78716C"/>
                 </a:solidFill>
@@ -24725,7 +24883,7 @@
               </a:spcAft>
             </a:pPr>
             <a:r>
-              <a:rPr sz="900">
+              <a:rPr sz="850">
                 <a:solidFill>
                   <a:srgbClr val="C8102E"/>
                 </a:solidFill>
@@ -24734,7 +24892,7 @@
               <a:t>▪  </a:t>
             </a:r>
             <a:r>
-              <a:rPr sz="900">
+              <a:rPr sz="850">
                 <a:solidFill>
                   <a:srgbClr val="78716C"/>
                 </a:solidFill>
@@ -24750,7 +24908,7 @@
               </a:spcAft>
             </a:pPr>
             <a:r>
-              <a:rPr sz="900">
+              <a:rPr sz="850">
                 <a:solidFill>
                   <a:srgbClr val="C8102E"/>
                 </a:solidFill>
@@ -24759,7 +24917,7 @@
               <a:t>▪  </a:t>
             </a:r>
             <a:r>
-              <a:rPr sz="900">
+              <a:rPr sz="850">
                 <a:solidFill>
                   <a:srgbClr val="78716C"/>
                 </a:solidFill>
@@ -24778,8 +24936,8 @@
         </p:nvSpPr>
         <p:spPr>
           <a:xfrm>
-            <a:off x="4343400" y="6071616"/>
-            <a:ext cx="3749039" cy="2331720"/>
+            <a:off x="3271266" y="3703320"/>
+            <a:ext cx="2695194" cy="2377440"/>
           </a:xfrm>
           <a:prstGeom prst="rect">
             <a:avLst/>
@@ -24823,8 +24981,8 @@
         </p:nvSpPr>
         <p:spPr>
           <a:xfrm>
-            <a:off x="4343400" y="6071616"/>
-            <a:ext cx="3749039" cy="64008"/>
+            <a:off x="3271266" y="3703320"/>
+            <a:ext cx="2695194" cy="64008"/>
           </a:xfrm>
           <a:prstGeom prst="rect">
             <a:avLst/>
@@ -24866,8 +25024,8 @@
         </p:nvSpPr>
         <p:spPr>
           <a:xfrm>
-            <a:off x="4507992" y="6181344"/>
-            <a:ext cx="3474720" cy="292608"/>
+            <a:off x="3408426" y="3813048"/>
+            <a:ext cx="2512313" cy="292608"/>
           </a:xfrm>
           <a:prstGeom prst="rect">
             <a:avLst/>
@@ -24882,7 +25040,7 @@
           <a:p>
             <a:pPr algn="l"/>
             <a:r>
-              <a:rPr sz="1050" b="1" i="0">
+              <a:rPr sz="1000" b="1" i="0">
                 <a:solidFill>
                   <a:srgbClr val="1C1917"/>
                 </a:solidFill>
@@ -24901,8 +25059,8 @@
         </p:nvSpPr>
         <p:spPr>
           <a:xfrm>
-            <a:off x="4507992" y="6528816"/>
-            <a:ext cx="3474720" cy="5486400"/>
+            <a:off x="3408426" y="4160520"/>
+            <a:ext cx="2512313" cy="5486400"/>
           </a:xfrm>
           <a:prstGeom prst="rect">
             <a:avLst/>
@@ -24921,7 +25079,7 @@
               </a:spcAft>
             </a:pPr>
             <a:r>
-              <a:rPr sz="900">
+              <a:rPr sz="850">
                 <a:solidFill>
                   <a:srgbClr val="C8102E"/>
                 </a:solidFill>
@@ -24930,7 +25088,7 @@
               <a:t>▪  </a:t>
             </a:r>
             <a:r>
-              <a:rPr sz="900">
+              <a:rPr sz="850">
                 <a:solidFill>
                   <a:srgbClr val="78716C"/>
                 </a:solidFill>
@@ -24946,7 +25104,7 @@
               </a:spcAft>
             </a:pPr>
             <a:r>
-              <a:rPr sz="900">
+              <a:rPr sz="850">
                 <a:solidFill>
                   <a:srgbClr val="C8102E"/>
                 </a:solidFill>
@@ -24955,7 +25113,7 @@
               <a:t>▪  </a:t>
             </a:r>
             <a:r>
-              <a:rPr sz="900">
+              <a:rPr sz="850">
                 <a:solidFill>
                   <a:srgbClr val="78716C"/>
                 </a:solidFill>
@@ -24971,7 +25129,7 @@
               </a:spcAft>
             </a:pPr>
             <a:r>
-              <a:rPr sz="900">
+              <a:rPr sz="850">
                 <a:solidFill>
                   <a:srgbClr val="C8102E"/>
                 </a:solidFill>
@@ -24980,7 +25138,7 @@
               <a:t>▪  </a:t>
             </a:r>
             <a:r>
-              <a:rPr sz="900">
+              <a:rPr sz="850">
                 <a:solidFill>
                   <a:srgbClr val="78716C"/>
                 </a:solidFill>
@@ -24996,7 +25154,7 @@
               </a:spcAft>
             </a:pPr>
             <a:r>
-              <a:rPr sz="900">
+              <a:rPr sz="850">
                 <a:solidFill>
                   <a:srgbClr val="C8102E"/>
                 </a:solidFill>
@@ -25005,7 +25163,7 @@
               <a:t>▪  </a:t>
             </a:r>
             <a:r>
-              <a:rPr sz="900">
+              <a:rPr sz="850">
                 <a:solidFill>
                   <a:srgbClr val="78716C"/>
                 </a:solidFill>
@@ -25024,8 +25182,8 @@
         </p:nvSpPr>
         <p:spPr>
           <a:xfrm>
-            <a:off x="8275319" y="6071616"/>
-            <a:ext cx="3749039" cy="2331720"/>
+            <a:off x="6131052" y="3703320"/>
+            <a:ext cx="2695194" cy="2377440"/>
           </a:xfrm>
           <a:prstGeom prst="rect">
             <a:avLst/>
@@ -25069,8 +25227,8 @@
         </p:nvSpPr>
         <p:spPr>
           <a:xfrm>
-            <a:off x="8275319" y="6071616"/>
-            <a:ext cx="3749039" cy="64008"/>
+            <a:off x="6131052" y="3703320"/>
+            <a:ext cx="2695194" cy="64008"/>
           </a:xfrm>
           <a:prstGeom prst="rect">
             <a:avLst/>
@@ -25112,8 +25270,8 @@
         </p:nvSpPr>
         <p:spPr>
           <a:xfrm>
-            <a:off x="8439911" y="6181344"/>
-            <a:ext cx="3474720" cy="292608"/>
+            <a:off x="6268212" y="3813048"/>
+            <a:ext cx="2512313" cy="292608"/>
           </a:xfrm>
           <a:prstGeom prst="rect">
             <a:avLst/>
@@ -25128,7 +25286,7 @@
           <a:p>
             <a:pPr algn="l"/>
             <a:r>
-              <a:rPr sz="1050" b="1" i="0">
+              <a:rPr sz="1000" b="1" i="0">
                 <a:solidFill>
                   <a:srgbClr val="1C1917"/>
                 </a:solidFill>
@@ -25147,8 +25305,8 @@
         </p:nvSpPr>
         <p:spPr>
           <a:xfrm>
-            <a:off x="8439911" y="6528816"/>
-            <a:ext cx="3474720" cy="5486400"/>
+            <a:off x="6268212" y="4160520"/>
+            <a:ext cx="2512313" cy="5486400"/>
           </a:xfrm>
           <a:prstGeom prst="rect">
             <a:avLst/>
@@ -25167,7 +25325,7 @@
               </a:spcAft>
             </a:pPr>
             <a:r>
-              <a:rPr sz="900">
+              <a:rPr sz="850">
                 <a:solidFill>
                   <a:srgbClr val="C8102E"/>
                 </a:solidFill>
@@ -25176,7 +25334,7 @@
               <a:t>▪  </a:t>
             </a:r>
             <a:r>
-              <a:rPr sz="900">
+              <a:rPr sz="850">
                 <a:solidFill>
                   <a:srgbClr val="78716C"/>
                 </a:solidFill>
@@ -25192,7 +25350,7 @@
               </a:spcAft>
             </a:pPr>
             <a:r>
-              <a:rPr sz="900">
+              <a:rPr sz="850">
                 <a:solidFill>
                   <a:srgbClr val="C8102E"/>
                 </a:solidFill>
@@ -25201,7 +25359,7 @@
               <a:t>▪  </a:t>
             </a:r>
             <a:r>
-              <a:rPr sz="900">
+              <a:rPr sz="850">
                 <a:solidFill>
                   <a:srgbClr val="78716C"/>
                 </a:solidFill>
@@ -25217,7 +25375,7 @@
               </a:spcAft>
             </a:pPr>
             <a:r>
-              <a:rPr sz="900">
+              <a:rPr sz="850">
                 <a:solidFill>
                   <a:srgbClr val="C8102E"/>
                 </a:solidFill>
@@ -25226,7 +25384,7 @@
               <a:t>▪  </a:t>
             </a:r>
             <a:r>
-              <a:rPr sz="900">
+              <a:rPr sz="850">
                 <a:solidFill>
                   <a:srgbClr val="78716C"/>
                 </a:solidFill>
@@ -25242,7 +25400,7 @@
               </a:spcAft>
             </a:pPr>
             <a:r>
-              <a:rPr sz="900">
+              <a:rPr sz="850">
                 <a:solidFill>
                   <a:srgbClr val="C8102E"/>
                 </a:solidFill>
@@ -25251,7 +25409,7 @@
               <a:t>▪  </a:t>
             </a:r>
             <a:r>
-              <a:rPr sz="900">
+              <a:rPr sz="850">
                 <a:solidFill>
                   <a:srgbClr val="78716C"/>
                 </a:solidFill>
@@ -25264,7 +25422,253 @@
       </p:sp>
       <p:sp>
         <p:nvSpPr>
-          <p:cNvPr id="31" name="TextBox 30"/>
+          <p:cNvPr id="31" name="Rectangle 30"/>
+          <p:cNvSpPr/>
+          <p:nvPr/>
+        </p:nvSpPr>
+        <p:spPr>
+          <a:xfrm>
+            <a:off x="8990838" y="3703320"/>
+            <a:ext cx="2695194" cy="2377440"/>
+          </a:xfrm>
+          <a:prstGeom prst="rect">
+            <a:avLst/>
+          </a:prstGeom>
+          <a:solidFill>
+            <a:srgbClr val="FFFFFF"/>
+          </a:solidFill>
+          <a:ln w="12700">
+            <a:solidFill>
+              <a:srgbClr val="D6D3D1"/>
+            </a:solidFill>
+          </a:ln>
+        </p:spPr>
+        <p:style>
+          <a:lnRef idx="1">
+            <a:schemeClr val="accent1"/>
+          </a:lnRef>
+          <a:fillRef idx="3">
+            <a:schemeClr val="accent1"/>
+          </a:fillRef>
+          <a:effectRef idx="2">
+            <a:schemeClr val="accent1"/>
+          </a:effectRef>
+          <a:fontRef idx="minor">
+            <a:schemeClr val="lt1"/>
+          </a:fontRef>
+        </p:style>
+        <p:txBody>
+          <a:bodyPr rtlCol="0" anchor="ctr"/>
+          <a:lstStyle/>
+          <a:p>
+            <a:pPr algn="ctr"/>
+          </a:p>
+        </p:txBody>
+      </p:sp>
+      <p:sp>
+        <p:nvSpPr>
+          <p:cNvPr id="32" name="Rectangle 31"/>
+          <p:cNvSpPr/>
+          <p:nvPr/>
+        </p:nvSpPr>
+        <p:spPr>
+          <a:xfrm>
+            <a:off x="8990838" y="3703320"/>
+            <a:ext cx="2695194" cy="64008"/>
+          </a:xfrm>
+          <a:prstGeom prst="rect">
+            <a:avLst/>
+          </a:prstGeom>
+          <a:solidFill>
+            <a:srgbClr val="C8102E"/>
+          </a:solidFill>
+          <a:ln>
+            <a:noFill/>
+          </a:ln>
+        </p:spPr>
+        <p:style>
+          <a:lnRef idx="1">
+            <a:schemeClr val="accent1"/>
+          </a:lnRef>
+          <a:fillRef idx="3">
+            <a:schemeClr val="accent1"/>
+          </a:fillRef>
+          <a:effectRef idx="2">
+            <a:schemeClr val="accent1"/>
+          </a:effectRef>
+          <a:fontRef idx="minor">
+            <a:schemeClr val="lt1"/>
+          </a:fontRef>
+        </p:style>
+        <p:txBody>
+          <a:bodyPr rtlCol="0" anchor="ctr"/>
+          <a:lstStyle/>
+          <a:p>
+            <a:pPr algn="ctr"/>
+          </a:p>
+        </p:txBody>
+      </p:sp>
+      <p:sp>
+        <p:nvSpPr>
+          <p:cNvPr id="33" name="TextBox 32"/>
+          <p:cNvSpPr txBox="1"/>
+          <p:nvPr/>
+        </p:nvSpPr>
+        <p:spPr>
+          <a:xfrm>
+            <a:off x="9127998" y="3813048"/>
+            <a:ext cx="2512313" cy="292608"/>
+          </a:xfrm>
+          <a:prstGeom prst="rect">
+            <a:avLst/>
+          </a:prstGeom>
+          <a:noFill/>
+        </p:spPr>
+        <p:txBody>
+          <a:bodyPr wrap="square">
+            <a:spAutoFit/>
+          </a:bodyPr>
+          <a:lstStyle/>
+          <a:p>
+            <a:pPr algn="l"/>
+            <a:r>
+              <a:rPr sz="1000" b="1" i="0">
+                <a:solidFill>
+                  <a:srgbClr val="1C1917"/>
+                </a:solidFill>
+                <a:latin typeface="Calibri"/>
+              </a:rPr>
+              <a:t>Live Notification Bell</a:t>
+            </a:r>
+          </a:p>
+        </p:txBody>
+      </p:sp>
+      <p:sp>
+        <p:nvSpPr>
+          <p:cNvPr id="34" name="TextBox 33"/>
+          <p:cNvSpPr txBox="1"/>
+          <p:nvPr/>
+        </p:nvSpPr>
+        <p:spPr>
+          <a:xfrm>
+            <a:off x="9127998" y="4160520"/>
+            <a:ext cx="2512313" cy="5486400"/>
+          </a:xfrm>
+          <a:prstGeom prst="rect">
+            <a:avLst/>
+          </a:prstGeom>
+          <a:noFill/>
+        </p:spPr>
+        <p:txBody>
+          <a:bodyPr wrap="square">
+            <a:spAutoFit/>
+          </a:bodyPr>
+          <a:lstStyle/>
+          <a:p>
+            <a:pPr>
+              <a:spcAft>
+                <a:spcPts val="500"/>
+              </a:spcAft>
+            </a:pPr>
+            <a:r>
+              <a:rPr sz="850">
+                <a:solidFill>
+                  <a:srgbClr val="C8102E"/>
+                </a:solidFill>
+                <a:latin typeface="Calibri"/>
+              </a:rPr>
+              <a:t>▪  </a:t>
+            </a:r>
+            <a:r>
+              <a:rPr sz="850">
+                <a:solidFill>
+                  <a:srgbClr val="78716C"/>
+                </a:solidFill>
+                <a:latin typeface="Calibri"/>
+              </a:rPr>
+              <a:t>Security alerts: new device/location login</a:t>
+            </a:r>
+          </a:p>
+          <a:p>
+            <a:pPr>
+              <a:spcAft>
+                <a:spcPts val="500"/>
+              </a:spcAft>
+            </a:pPr>
+            <a:r>
+              <a:rPr sz="850">
+                <a:solidFill>
+                  <a:srgbClr val="C8102E"/>
+                </a:solidFill>
+                <a:latin typeface="Calibri"/>
+              </a:rPr>
+              <a:t>▪  </a:t>
+            </a:r>
+            <a:r>
+              <a:rPr sz="850">
+                <a:solidFill>
+                  <a:srgbClr val="78716C"/>
+                </a:solidFill>
+                <a:latin typeface="Calibri"/>
+              </a:rPr>
+              <a:t>Pending approval queue — one tap to Sign tab</a:t>
+            </a:r>
+          </a:p>
+          <a:p>
+            <a:pPr>
+              <a:spcAft>
+                <a:spcPts val="500"/>
+              </a:spcAft>
+            </a:pPr>
+            <a:r>
+              <a:rPr sz="850">
+                <a:solidFill>
+                  <a:srgbClr val="C8102E"/>
+                </a:solidFill>
+                <a:latin typeface="Calibri"/>
+              </a:rPr>
+              <a:t>▪  </a:t>
+            </a:r>
+            <a:r>
+              <a:rPr sz="850">
+                <a:solidFill>
+                  <a:srgbClr val="78716C"/>
+                </a:solidFill>
+                <a:latin typeface="Calibri"/>
+              </a:rPr>
+              <a:t>Cooling-off countdowns with live progress bar</a:t>
+            </a:r>
+          </a:p>
+          <a:p>
+            <a:pPr>
+              <a:spcAft>
+                <a:spcPts val="500"/>
+              </a:spcAft>
+            </a:pPr>
+            <a:r>
+              <a:rPr sz="850">
+                <a:solidFill>
+                  <a:srgbClr val="C8102E"/>
+                </a:solidFill>
+                <a:latin typeface="Calibri"/>
+              </a:rPr>
+              <a:t>▪  </a:t>
+            </a:r>
+            <a:r>
+              <a:rPr sz="850">
+                <a:solidFill>
+                  <a:srgbClr val="78716C"/>
+                </a:solidFill>
+                <a:latin typeface="Calibri"/>
+              </a:rPr>
+              <a:t>Stalled co-signer escalations with RM status</a:t>
+            </a:r>
+          </a:p>
+        </p:txBody>
+      </p:sp>
+      <p:sp>
+        <p:nvSpPr>
+          <p:cNvPr id="35" name="TextBox 34"/>
           <p:cNvSpPr txBox="1"/>
           <p:nvPr/>
         </p:nvSpPr>
@@ -25299,7 +25703,7 @@
       </p:sp>
       <p:sp>
         <p:nvSpPr>
-          <p:cNvPr id="32" name="TextBox 31"/>
+          <p:cNvPr id="36" name="TextBox 35"/>
           <p:cNvSpPr txBox="1"/>
           <p:nvPr/>
         </p:nvSpPr>

</xml_diff>